<commit_message>
build(assets): regenerar PDF+PPTX de las 112 clases resueltas y arreglar enlaces README
- Regenera guia-explicativa.pdf y presentacion.pptx (+ mirrors docs/) de las 112
  clases cuyo notebook paso de stub a contenido real, mas la 011 (README tocado).
  El apendice PDF y la slide de codigo ahora reflejan el primer bloque real.
- Corrige 13 enlaces "Version profundizada 2026" que apuntaban a numeracion vieja
  ../NNNb-<slug>/ inexistente -> carpeta real ../MMM-<slug>/ (mismo slug).

Co-Authored-By: Claude Opus 4.8 <noreply@anthropic.com>
</commit_message>
<xml_diff>
--- a/classes/parte-1-machine-learning-clasico/050-panorama-del-ml-tipos-batch-vs-online-instance-vs-model-based/clase-050-panorama-del-ml-tipos-batch-vs-online-instance-vs-model-based-presentacion.pptx
+++ b/classes/parte-1-machine-learning-clasico/050-panorama-del-ml-tipos-batch-vs-online-instance-vs-model-based/clase-050-panorama-del-ml-tipos-batch-vs-online-instance-vs-model-based-presentacion.pptx
@@ -4955,7 +4955,7 @@
                 </a:solidFill>
                 <a:latin typeface="Segoe UI"/>
               </a:rPr>
-              <a:t>Primer bloque ejecutable del notebook.</a:t>
+              <a:t>Ubicamos cada algoritmo en la grilla (supervisión × batch/online × instance/model). Comparamos KNN (instance-based) contra LogisticRegression (model-based) y mostramos el patrón canónico de online learning con partial_fit.</a:t>
             </a:r>
           </a:p>
         </p:txBody>
@@ -5042,7 +5042,235 @@
                 </a:solidFill>
                 <a:latin typeface="Courier New"/>
               </a:rPr>
-              <a:t># Imports y configuración inicial</a:t>
+              <a:t>import numpy as np</a:t>
+            </a:r>
+          </a:p>
+          <a:p>
+            <a:pPr>
+              <a:defRPr sz="1200" b="0">
+                <a:solidFill>
+                  <a:srgbClr val="F8FAFC"/>
+                </a:solidFill>
+                <a:latin typeface="Courier New"/>
+              </a:defRPr>
+            </a:pPr>
+            <a:r>
+              <a:rPr sz="1200" b="0">
+                <a:solidFill>
+                  <a:srgbClr val="F8FAFC"/>
+                </a:solidFill>
+                <a:latin typeface="Courier New"/>
+              </a:rPr>
+              <a:t>import pandas as pd</a:t>
+            </a:r>
+          </a:p>
+          <a:p>
+            <a:pPr>
+              <a:defRPr sz="1200" b="0">
+                <a:solidFill>
+                  <a:srgbClr val="F8FAFC"/>
+                </a:solidFill>
+                <a:latin typeface="Courier New"/>
+              </a:defRPr>
+            </a:pPr>
+            <a:r>
+              <a:rPr sz="1200" b="0">
+                <a:solidFill>
+                  <a:srgbClr val="F8FAFC"/>
+                </a:solidFill>
+                <a:latin typeface="Courier New"/>
+              </a:rPr>
+              <a:t>import pickle</a:t>
+            </a:r>
+          </a:p>
+          <a:p>
+            <a:pPr>
+              <a:defRPr sz="1200" b="0">
+                <a:solidFill>
+                  <a:srgbClr val="F8FAFC"/>
+                </a:solidFill>
+                <a:latin typeface="Courier New"/>
+              </a:defRPr>
+            </a:pPr>
+            <a:r>
+              <a:rPr sz="1200" b="0">
+                <a:solidFill>
+                  <a:srgbClr val="F8FAFC"/>
+                </a:solidFill>
+                <a:latin typeface="Courier New"/>
+              </a:rPr>
+              <a:t>import matplotlib.pyplot as plt</a:t>
+            </a:r>
+          </a:p>
+          <a:p>
+            <a:pPr>
+              <a:defRPr sz="1200" b="0">
+                <a:solidFill>
+                  <a:srgbClr val="F8FAFC"/>
+                </a:solidFill>
+                <a:latin typeface="Courier New"/>
+              </a:defRPr>
+            </a:pPr>
+            <a:r>
+              <a:rPr sz="1200" b="0">
+                <a:solidFill>
+                  <a:srgbClr val="F8FAFC"/>
+                </a:solidFill>
+                <a:latin typeface="Courier New"/>
+              </a:rPr>
+              <a:t>from sklearn.datasets import load_iris, make_regression</a:t>
+            </a:r>
+          </a:p>
+          <a:p>
+            <a:pPr>
+              <a:defRPr sz="1200" b="0">
+                <a:solidFill>
+                  <a:srgbClr val="F8FAFC"/>
+                </a:solidFill>
+                <a:latin typeface="Courier New"/>
+              </a:defRPr>
+            </a:pPr>
+            <a:r>
+              <a:rPr sz="1200" b="0">
+                <a:solidFill>
+                  <a:srgbClr val="F8FAFC"/>
+                </a:solidFill>
+                <a:latin typeface="Courier New"/>
+              </a:rPr>
+              <a:t>from sklearn.neighbors import KNeighborsClassifier</a:t>
+            </a:r>
+          </a:p>
+          <a:p>
+            <a:pPr>
+              <a:defRPr sz="1200" b="0">
+                <a:solidFill>
+                  <a:srgbClr val="F8FAFC"/>
+                </a:solidFill>
+                <a:latin typeface="Courier New"/>
+              </a:defRPr>
+            </a:pPr>
+            <a:r>
+              <a:rPr sz="1200" b="0">
+                <a:solidFill>
+                  <a:srgbClr val="F8FAFC"/>
+                </a:solidFill>
+                <a:latin typeface="Courier New"/>
+              </a:rPr>
+              <a:t>from sklearn.linear_model import LogisticRegression, SGDRegressor</a:t>
+            </a:r>
+          </a:p>
+          <a:p>
+            <a:pPr>
+              <a:defRPr sz="1200" b="0">
+                <a:solidFill>
+                  <a:srgbClr val="F8FAFC"/>
+                </a:solidFill>
+                <a:latin typeface="Courier New"/>
+              </a:defRPr>
+            </a:pPr>
+            <a:r>
+              <a:rPr sz="1200" b="0">
+                <a:solidFill>
+                  <a:srgbClr val="F8FAFC"/>
+                </a:solidFill>
+                <a:latin typeface="Courier New"/>
+              </a:rPr>
+              <a:t>from sklearn.model_selection import train_test_split</a:t>
+            </a:r>
+          </a:p>
+          <a:p>
+            <a:pPr>
+              <a:defRPr sz="1200" b="0">
+                <a:solidFill>
+                  <a:srgbClr val="F8FAFC"/>
+                </a:solidFill>
+                <a:latin typeface="Courier New"/>
+              </a:defRPr>
+            </a:pPr>
+            <a:r>
+              <a:rPr sz="1200" b="0">
+                <a:solidFill>
+                  <a:srgbClr val="F8FAFC"/>
+                </a:solidFill>
+                <a:latin typeface="Courier New"/>
+              </a:rPr>
+              <a:t>from sklearn.preprocessing import StandardScaler</a:t>
+            </a:r>
+          </a:p>
+          <a:p>
+            <a:pPr>
+              <a:defRPr sz="1200" b="0">
+                <a:solidFill>
+                  <a:srgbClr val="F8FAFC"/>
+                </a:solidFill>
+                <a:latin typeface="Courier New"/>
+              </a:defRPr>
+            </a:pPr>
+            <a:r>
+              <a:rPr sz="1200" b="0">
+                <a:solidFill>
+                  <a:srgbClr val="F8FAFC"/>
+                </a:solidFill>
+                <a:latin typeface="Courier New"/>
+              </a:rPr>
+              <a:t>from sklearn.metrics import accuracy_score, mean_squared_error</a:t>
+            </a:r>
+          </a:p>
+          <a:p>
+            <a:pPr>
+              <a:defRPr sz="1200" b="0">
+                <a:solidFill>
+                  <a:srgbClr val="F8FAFC"/>
+                </a:solidFill>
+                <a:latin typeface="Courier New"/>
+              </a:defRPr>
+            </a:pPr>
+            <a:r>
+              <a:rPr sz="1200" b="0">
+                <a:solidFill>
+                  <a:srgbClr val="F8FAFC"/>
+                </a:solidFill>
+                <a:latin typeface="Courier New"/>
+              </a:rPr>
+              <a:t> </a:t>
+            </a:r>
+          </a:p>
+          <a:p>
+            <a:pPr>
+              <a:defRPr sz="1200" b="0">
+                <a:solidFill>
+                  <a:srgbClr val="F8FAFC"/>
+                </a:solidFill>
+                <a:latin typeface="Courier New"/>
+              </a:defRPr>
+            </a:pPr>
+            <a:r>
+              <a:rPr sz="1200" b="0">
+                <a:solidFill>
+                  <a:srgbClr val="F8FAFC"/>
+                </a:solidFill>
+                <a:latin typeface="Courier New"/>
+              </a:rPr>
+              <a:t>np.random.seed(42)</a:t>
+            </a:r>
+          </a:p>
+          <a:p>
+            <a:pPr>
+              <a:defRPr sz="1200" b="0">
+                <a:solidFill>
+                  <a:srgbClr val="F8FAFC"/>
+                </a:solidFill>
+                <a:latin typeface="Courier New"/>
+              </a:defRPr>
+            </a:pPr>
+            <a:r>
+              <a:rPr sz="1200" b="0">
+                <a:solidFill>
+                  <a:srgbClr val="F8FAFC"/>
+                </a:solidFill>
+                <a:latin typeface="Courier New"/>
+              </a:rPr>
+              <a:t>print('setup ok')</a:t>
             </a:r>
           </a:p>
         </p:txBody>

</xml_diff>